<commit_message>
Add the defence speech (docx) for the SINTEZ deck; make the slide-12 note precise
Co-Authored-By: Claude Sonnet 5.5 <noreply@anthropic.com>
Claude-Session: https://claude.ai/code/session_01JvqFrw5NVZWE17PBaQ4txM
</commit_message>
<xml_diff>
--- a/presentation/SINTEZ_IFARP-2026.pptx
+++ b/presentation/SINTEZ_IFARP-2026.pptx
@@ -121,13 +121,13 @@
   <p:extLst>
     <p:ext uri="{521415D9-36F7-43E2-AB2F-B90AF26B5E84}">
       <p14:sectionLst xmlns:p14="http://schemas.microsoft.com/office/powerpoint/2010/main">
-        <p14:section name="Кіріспе" id="{6bc45157-3f37-d94f-f974-e20c2747330e}">
+        <p14:section name="Кіріспе" id="{745fc207-4937-e4a5-6ba7-49cdff31d4e8}">
           <p14:sldIdLst>
             <p14:sldId id="256"/>
             <p14:sldId id="257"/>
           </p14:sldIdLst>
         </p14:section>
-        <p14:section name="Жүйе" id="{444254a2-60b9-f48e-49a7-b6443a64e710}">
+        <p14:section name="Жүйе" id="{bd1e58a3-fc29-14f3-9d8a-c566b5571afd}">
           <p14:sldIdLst>
             <p14:sldId id="258"/>
             <p14:sldId id="259"/>
@@ -137,19 +137,19 @@
             <p14:sldId id="263"/>
           </p14:sldIdLst>
         </p14:section>
-        <p14:section name="Валидация" id="{69199a13-297d-1467-ca75-737c2bb40404}">
+        <p14:section name="Валидация" id="{4698561b-713e-4c29-d3f5-f3443689058f}">
           <p14:sldIdLst>
             <p14:sldId id="264"/>
           </p14:sldIdLst>
         </p14:section>
-        <p14:section name="AI" id="{e28c09b4-70dc-cf79-21d6-853e4e63ba4e}">
+        <p14:section name="AI" id="{64b8bdca-5ffa-a53e-0788-05de59b189be}">
           <p14:sldIdLst>
             <p14:sldId id="265"/>
             <p14:sldId id="266"/>
             <p14:sldId id="267"/>
           </p14:sldIdLst>
         </p14:section>
-        <p14:section name="Қорытынды" id="{69057711-3278-716d-70f7-765d37ad0d76}">
+        <p14:section name="Қорытынды" id="{3a13dabd-59fb-f66a-4b0d-3bb388d72b2b}">
           <p14:sldIdLst>
             <p14:sldId id="268"/>
             <p14:sldId id="269"/>
@@ -1576,7 +1576,7 @@
           <a:p>
             <a:r>
               <a:rPr lang="en-US" dirty="0"/>
-              <a:t>Тұйық контур: симулятор — датчиктер мен кідіріс — нейрожелілік контроллер — QP қауіпсіздік сүзгісі — катушкаларға кернеу. Плазма тік тұрақсыз, тіпті ашық контурда 30 эпизодтың тек 2-інде ғана аман қалады. Рандомдалған плантта ПИД 30-дан 24-те, PPO 28-де аман қалды, орын қатесі 22 мм-ден 6 мм-ге дейін азайды. Бұл тек модельдеу нәтижесі, нақты қондырғыда тексерілмеген.</a:t>
+              <a:t>Тұйық контур: симулятор — датчиктер мен кідіріс — нейрожелілік контроллер — QP қауіпсіздік сүзгісі — катушкаларға кернеу. Плазма тік тұрақсыз, ашық контурда номиналды плантта 30 эпизодтың ешқайсысында плазма ұсталмайды (рандомдалғанында тек екеуінде). Рандомдалған плантта ПИД 30-дан 24-те, PPO 28-де аман қалды, орын қатесі 22 мм-ден 6 мм-ге дейін азайды. Бұл тек модельдеу нәтижесі, нақты қондырғыда тексерілмеген.</a:t>
             </a:r>
             <a:endParaRPr lang="en-US" dirty="0"/>
           </a:p>

</xml_diff>